<commit_message>
Fix em-dash rule violations across the deck (rule 1, no em-dashes anywhere in this repo)
</commit_message>
<xml_diff>
--- a/presentation/slides_draft.pptx
+++ b/presentation/slides_draft.pptx
@@ -2794,7 +2794,7 @@
                 <a:ea typeface="Calibri" pitchFamily="34" charset="-122"/>
                 <a:cs typeface="Calibri" pitchFamily="34" charset="-120"/>
               </a:rPr>
-              <a:t>Sells volatility on SPY only when it is measurably expensive. Every decision it makes — including every refusal — is a signed artifact you can verify yourself.</a:t>
+              <a:t>Sells volatility on SPY only when it is measurably expensive. Every decision it makes, including every refusal, is a signed artifact you can verify yourself.</a:t>
             </a:r>
             <a:endParaRPr lang="en-US" sz="1550" dirty="0"/>
           </a:p>
@@ -2856,7 +2856,7 @@
                 <a:ea typeface="Calibri" pitchFamily="34" charset="-122"/>
                 <a:cs typeface="Calibri" pitchFamily="34" charset="-120"/>
               </a:rPr>
-              <a:t>Nilay Toshniwal  —  Solo entry</a:t>
+              <a:t>Nilay Toshniwal  ·  Solo entry</a:t>
             </a:r>
             <a:endParaRPr lang="en-US" sz="1250" dirty="0"/>
           </a:p>
@@ -3070,7 +3070,7 @@
                 <a:ea typeface="Calibri" pitchFamily="34" charset="-122"/>
                 <a:cs typeface="Calibri" pitchFamily="34" charset="-120"/>
               </a:rPr>
-              <a:t>Rather than commit to one tenor and hope, three configurations run as fully isolated shadow agents — hourly, against the real live market, through the agent's own valid trading window. Each is a genuine decision, just never sent as an order.</a:t>
+              <a:t>Rather than commit to one tenor and hope, three configurations run as fully isolated shadow agents, hourly, against the real live market, through the agent's own valid trading window. Each is a genuine decision, just never sent as an order.</a:t>
             </a:r>
             <a:endParaRPr lang="en-US" sz="1350" dirty="0"/>
           </a:p>
@@ -3865,7 +3865,7 @@
                 <a:ea typeface="Calibri" pitchFamily="34" charset="-122"/>
                 <a:cs typeface="Calibri" pitchFamily="34" charset="-120"/>
               </a:rPr>
-              <a:t>building this comparison harness found and fixed 4 real production bugs before the live week could hit them — a Merkle-root path collision, a UTC/ET timestamp mismatch, and two separate silent scheduling failures.</a:t>
+              <a:t>building this comparison harness found and fixed 4 real production bugs before the live week could hit them: a Merkle-root path collision, a UTC/ET timestamp mismatch, and two separate silent scheduling failures.</a:t>
             </a:r>
             <a:endParaRPr lang="en-US" sz="1250" dirty="0"/>
           </a:p>
@@ -4148,7 +4148,7 @@
                 <a:ea typeface="Calibri" pitchFamily="34" charset="-122"/>
                 <a:cs typeface="Calibri" pitchFamily="34" charset="-120"/>
               </a:rPr>
-              <a:t>A SHA-256 Merkle tree over every decision — domain-separated leaves and nodes, root sealed before outcomes are known. Anyone can recompute it and confirm nothing was edited after the fact.</a:t>
+              <a:t>A SHA-256 Merkle tree over every decision: domain-separated leaves and nodes, root sealed before outcomes are known. Anyone can recompute it and confirm nothing was edited after the fact.</a:t>
             </a:r>
             <a:endParaRPr lang="en-US" sz="1450" dirty="0"/>
           </a:p>
@@ -4190,7 +4190,7 @@
                 <a:ea typeface="Calibri" pitchFamily="34" charset="-122"/>
                 <a:cs typeface="Calibri" pitchFamily="34" charset="-120"/>
               </a:rPr>
-              <a:t>The judge doesn’t have to trust the operator — which is the whole point when the operator has an incentive to look good.</a:t>
+              <a:t>The judge doesn’t have to trust the operator, which is the whole point when the operator has an incentive to look good.</a:t>
             </a:r>
             <a:endParaRPr lang="en-US" sz="1500" dirty="0"/>
           </a:p>
@@ -4725,7 +4725,7 @@
                 <a:ea typeface="Calibri" pitchFamily="34" charset="-122"/>
                 <a:cs typeface="Calibri" pitchFamily="34" charset="-120"/>
               </a:rPr>
-              <a:t>estimated chance of even ONE trade across the 4.5-day judged window, at the measured VRP distribution — and that’s the optimistic side.</a:t>
+              <a:t>estimated chance of even ONE trade across the 4.5-day judged window, at the measured VRP distribution, and that’s the optimistic side.</a:t>
             </a:r>
             <a:endParaRPr lang="en-US" sz="1250" dirty="0"/>
           </a:p>
@@ -4790,7 +4790,7 @@
                 <a:ea typeface="Calibri" pitchFamily="34" charset="-122"/>
                 <a:cs typeface="Calibri" pitchFamily="34" charset="-120"/>
               </a:rPr>
-              <a:t>This is not a bug. The pre-registered research always expected roughly one trade per week at this sizing — refusal is the strategy working, not failing. But P&amp;L Performance is a judged criterion, and an agent that refuses all week scores zero on it.</a:t>
+              <a:t>This is not a bug. The pre-registered research always expected roughly one trade per week at this sizing. Refusal is the strategy working, not failing. But P&amp;L Performance is a judged criterion, and an agent that refuses all week scores zero on it.</a:t>
             </a:r>
             <a:endParaRPr lang="en-US" sz="1450" dirty="0"/>
           </a:p>
@@ -5050,7 +5050,7 @@
                 <a:ea typeface="Calibri" pitchFamily="34" charset="-122"/>
                 <a:cs typeface="Calibri" pitchFamily="34" charset="-120"/>
               </a:rPr>
-              <a:t>DRAFT — UPDATE DURING THE LIVE WEEK</a:t>
+              <a:t>DRAFT: UPDATE DURING THE LIVE WEEK</a:t>
             </a:r>
             <a:endParaRPr lang="en-US" sz="1300" dirty="0"/>
           </a:p>
@@ -5572,7 +5572,7 @@
                 <a:ea typeface="Calibri" pitchFamily="34" charset="-122"/>
                 <a:cs typeface="Calibri" pitchFamily="34" charset="-120"/>
               </a:rPr>
-              <a:t>Refusal is the product, not a fallback — measured every cycle, logged every time</a:t>
+              <a:t>Refusal is the product, not a fallback. Measured every cycle, logged every time</a:t>
             </a:r>
             <a:endParaRPr lang="en-US" sz="1550" dirty="0"/>
           </a:p>
@@ -5690,7 +5690,7 @@
                 <a:ea typeface="Calibri" pitchFamily="34" charset="-122"/>
                 <a:cs typeface="Calibri" pitchFamily="34" charset="-120"/>
               </a:rPr>
-              <a:t>A verifiable, tamper-evident decision trail — not a claim, a recomputation</a:t>
+              <a:t>A verifiable, tamper-evident decision trail: not a claim, a recomputation</a:t>
             </a:r>
             <a:endParaRPr lang="en-US" sz="1550" dirty="0"/>
           </a:p>
@@ -6163,7 +6163,7 @@
                 <a:ea typeface="Calibri" pitchFamily="34" charset="-122"/>
                 <a:cs typeface="Calibri" pitchFamily="34" charset="-120"/>
               </a:rPr>
-              <a:t>Most trading agents are built to trade. This one measures whether the premium is actually worth selling — and says no when it isn’t.</a:t>
+              <a:t>Most trading agents are built to trade. This one measures whether the premium is actually worth selling, and says no when it isn’t.</a:t>
             </a:r>
             <a:endParaRPr lang="en-US" sz="1600" dirty="0"/>
           </a:p>
@@ -6416,7 +6416,7 @@
                 <a:ea typeface="Calibri" pitchFamily="34" charset="-122"/>
                 <a:cs typeface="Calibri" pitchFamily="34" charset="-120"/>
               </a:rPr>
-              <a:t>We call that gap the volatility risk premium (VRP). It is a well-documented structural feature of index options — buyers of protection pay more than the realised outcome justifies, on average.</a:t>
+              <a:t>We call that gap the volatility risk premium (VRP). It is a well-documented structural feature of index options: buyers of protection pay more than the realised outcome justifies, on average.</a:t>
             </a:r>
             <a:endParaRPr lang="en-US" sz="1500" dirty="0"/>
           </a:p>
@@ -6458,7 +6458,7 @@
                 <a:ea typeface="Calibri" pitchFamily="34" charset="-122"/>
                 <a:cs typeface="Calibri" pitchFamily="34" charset="-120"/>
               </a:rPr>
-              <a:t>The agent sells that gap with a defined-risk iron condor on SPY — and only enters when the premium is measurably rich enough, at the exact strikes it is about to sell, to be worth the risk.</a:t>
+              <a:t>The agent sells that gap with a defined-risk iron condor on SPY, and only enters when the premium is measurably rich enough, at the exact strikes it is about to sell, to be worth the risk.</a:t>
             </a:r>
             <a:endParaRPr lang="en-US" sz="1500" dirty="0"/>
           </a:p>
@@ -6747,7 +6747,7 @@
                 <a:ea typeface="Calibri" pitchFamily="34" charset="-122"/>
                 <a:cs typeface="Calibri" pitchFamily="34" charset="-120"/>
               </a:rPr>
-              <a:t> — refusal is the default, not the exception.</a:t>
+              <a:t>, refusal is the default, not the exception.</a:t>
             </a:r>
             <a:endParaRPr lang="en-US" sz="1200" dirty="0"/>
           </a:p>
@@ -7059,7 +7059,7 @@
                 <a:ea typeface="Calibri" pitchFamily="34" charset="-122"/>
                 <a:cs typeface="Calibri" pitchFamily="34" charset="-120"/>
               </a:rPr>
-              <a:t>Six trials, one bar, committed to git before any result existed — provable from the commit timestamps.</a:t>
+              <a:t>Six trials, one bar, committed to git before any result existed, provable from the commit timestamps.</a:t>
             </a:r>
             <a:endParaRPr lang="en-US" sz="1350" dirty="0"/>
           </a:p>
@@ -7484,7 +7484,7 @@
                 <a:ea typeface="Calibri" pitchFamily="34" charset="-122"/>
                 <a:cs typeface="Calibri" pitchFamily="34" charset="-120"/>
               </a:rPr>
-              <a:t>“Few trials, long window” is the fix — not a lower bar.</a:t>
+              <a:t>“Few trials, long window” is the fix, not a lower bar.</a:t>
             </a:r>
             <a:endParaRPr lang="en-US" sz="1350" dirty="0"/>
           </a:p>
@@ -7597,7 +7597,7 @@
                 <a:ea typeface="Cambria" pitchFamily="34" charset="-122"/>
                 <a:cs typeface="Cambria" pitchFamily="34" charset="-120"/>
               </a:rPr>
-              <a:t>The edge is real — and it clears</a:t>
+              <a:t>The edge is real, and it clears</a:t>
             </a:r>
             <a:endParaRPr lang="en-US" sz="3200" dirty="0"/>
           </a:p>
@@ -8040,7 +8040,7 @@
                 <a:ea typeface="Calibri" pitchFamily="34" charset="-122"/>
                 <a:cs typeface="Calibri" pitchFamily="34" charset="-120"/>
               </a:rPr>
-              <a:t>21-day forward windows sampled daily overlap by 20 of 21 days — the naive t-stat is invalid. The correction shrinks it ~4x. H1 still clears the bar with room to spare.</a:t>
+              <a:t>21-day forward windows sampled daily overlap by 20 of 21 days, so the naive t-stat is invalid. The correction shrinks it ~4x. H1 still clears the bar with room to spare.</a:t>
             </a:r>
             <a:endParaRPr lang="en-US" sz="1350" dirty="0"/>
           </a:p>
@@ -8428,7 +8428,7 @@
                 <a:ea typeface="Calibri" pitchFamily="34" charset="-122"/>
                 <a:cs typeface="Calibri" pitchFamily="34" charset="-120"/>
               </a:rPr>
-              <a:t>Failed its own pre-registered 15% error gate at 26.78%. VIX is a variance-swap rate, not ATM vol — fixed and re-gated at 10.75%.</a:t>
+              <a:t>Failed its own pre-registered 15% error gate at 26.78%. VIX is a variance-swap rate, not ATM vol. Fixed and re-gated at 10.75%.</a:t>
             </a:r>
             <a:endParaRPr lang="en-US" sz="1300" dirty="0"/>
           </a:p>
@@ -8536,7 +8536,7 @@
                 <a:ea typeface="Calibri" pitchFamily="34" charset="-122"/>
                 <a:cs typeface="Calibri" pitchFamily="34" charset="-120"/>
               </a:rPr>
-              <a:t>Doubling transaction costs improved its Sharpe (+1.614 → +1.728) — impossible if the edge were clean. Disclosed as a fragility flag, not hidden.</a:t>
+              <a:t>Doubling transaction costs improved its Sharpe (+1.614 to +1.728), impossible if the edge were clean. Disclosed as a fragility flag, not hidden.</a:t>
             </a:r>
             <a:endParaRPr lang="en-US" sz="1300" dirty="0"/>
           </a:p>
@@ -8708,7 +8708,7 @@
                 <a:ea typeface="Cambria" pitchFamily="34" charset="-122"/>
                 <a:cs typeface="Cambria" pitchFamily="34" charset="-120"/>
               </a:rPr>
-              <a:t>best-backtested one — on purpose</a:t>
+              <a:t>best-backtested one, on purpose</a:t>
             </a:r>
             <a:endParaRPr lang="en-US" sz="3200" dirty="0"/>
           </a:p>
@@ -8805,7 +8805,7 @@
                 <a:ea typeface="Calibri" pitchFamily="34" charset="-122"/>
                 <a:cs typeface="Calibri" pitchFamily="34" charset="-120"/>
               </a:rPr>
-              <a:t>Both gold bars clear the bar. T7 (5–10 DTE) is the newest, best result and does not show T6’s cost-anomaly. But T4 (7–14 DTE) is what’s live — chosen for the 4.5-day judging window, not the backtest leaderboard:</a:t>
+              <a:t>Both gold bars clear the bar. T7 (5–10 DTE) is the newest, best result and does not show T6’s cost-anomaly. But T4 (7–14 DTE) is what’s live, chosen for the 4.5-day judging window, not the backtest leaderboard:</a:t>
             </a:r>
             <a:endParaRPr lang="en-US" sz="1250" dirty="0"/>
           </a:p>
@@ -8982,7 +8982,7 @@
                 <a:ea typeface="Cambria" pitchFamily="34" charset="-122"/>
                 <a:cs typeface="Cambria" pitchFamily="34" charset="-120"/>
               </a:rPr>
-              <a:t>Market data in, a decision out —</a:t>
+              <a:t>Market data in, a decision out:</a:t>
             </a:r>
             <a:endParaRPr lang="en-US" sz="3200" dirty="0"/>
           </a:p>
@@ -9651,7 +9651,7 @@
                 <a:ea typeface="Calibri" pitchFamily="34" charset="-122"/>
                 <a:cs typeface="Calibri" pitchFamily="34" charset="-120"/>
               </a:rPr>
-              <a:t>Circuit breakers can halt the whole pipeline at any gate — a halt is not the same decision as a refusal, and both are recorded differently.</a:t>
+              <a:t>Circuit breakers can halt the whole pipeline at any gate. A halt is not the same decision as a refusal, and both are recorded differently.</a:t>
             </a:r>
             <a:endParaRPr lang="en-US" sz="1150" dirty="0"/>
           </a:p>
@@ -9960,7 +9960,7 @@
                 <a:ea typeface="Calibri" pitchFamily="34" charset="-122"/>
                 <a:cs typeface="Calibri" pitchFamily="34" charset="-120"/>
               </a:rPr>
-              <a:t>Each cycle runs in its own subprocess with a hard OS timeout — an in-process timer can't rescue a thread stuck inside a syscall, but killing the process can.</a:t>
+              <a:t>Each cycle runs in its own subprocess with a hard OS timeout: an in-process timer can't rescue a thread stuck inside a syscall, but killing the process can.</a:t>
             </a:r>
             <a:endParaRPr lang="en-US" sz="980" dirty="0"/>
           </a:p>
@@ -10402,7 +10402,7 @@
                 <a:ea typeface="Calibri" pitchFamily="34" charset="-122"/>
                 <a:cs typeface="Calibri" pitchFamily="34" charset="-120"/>
               </a:rPr>
-              <a:t>Daily loss limit, portfolio drawdown halt, consecutive-loss pause — distinguished in code from an ordinary refusal.</a:t>
+              <a:t>Daily loss limit, portfolio drawdown halt, consecutive-loss pause, distinguished in code from an ordinary refusal.</a:t>
             </a:r>
             <a:endParaRPr lang="en-US" sz="1200" dirty="0"/>
           </a:p>
@@ -10736,7 +10736,7 @@
                 <a:ea typeface="Calibri" pitchFamily="34" charset="-122"/>
                 <a:cs typeface="Calibri" pitchFamily="34" charset="-120"/>
               </a:rPr>
-              <a:t>5 concurrent @ 3% (15% cap), a deliberate, recorded deviation from 1% research sizing — hard-capped, never open-ended.</a:t>
+              <a:t>5 concurrent @ 3% (15% cap), a deliberate, recorded deviation from 1% research sizing. Hard-capped, never open-ended.</a:t>
             </a:r>
             <a:endParaRPr lang="en-US" sz="1200" dirty="0"/>
           </a:p>

</xml_diff>